<commit_message>
Update final presentation PowerPoint
Co-Authored-By: Claude Sonnet 4.6 <noreply@anthropic.com>
</commit_message>
<xml_diff>
--- a/Math370_Final_Presentation.pptx
+++ b/Math370_Final_Presentation.pptx
@@ -8,9 +8,9 @@
     <p:sldId id="256" r:id="rId2"/>
     <p:sldId id="257" r:id="rId3"/>
     <p:sldId id="258" r:id="rId4"/>
-    <p:sldId id="260" r:id="rId5"/>
+    <p:sldId id="262" r:id="rId5"/>
     <p:sldId id="259" r:id="rId6"/>
-    <p:sldId id="261" r:id="rId7"/>
+    <p:sldId id="263" r:id="rId7"/>
   </p:sldIdLst>
   <p:sldSz cx="12192000" cy="6858000"/>
   <p:notesSz cx="6858000" cy="9144000"/>
@@ -3525,12 +3525,20 @@
 <file path=ppt/slides/slide4.xml><?xml version="1.0" encoding="utf-8"?>
 <p:sld xmlns:a="http://schemas.openxmlformats.org/drawingml/2006/main" xmlns:r="http://schemas.openxmlformats.org/officeDocument/2006/relationships" xmlns:p="http://schemas.openxmlformats.org/presentationml/2006/main">
   <p:cSld>
+    <p:bg>
+      <p:bgPr>
+        <a:solidFill>
+          <a:srgbClr val="111320"/>
+        </a:solidFill>
+        <a:effectLst/>
+      </p:bgPr>
+    </p:bg>
     <p:spTree>
       <p:nvGrpSpPr>
         <p:cNvPr id="1" name="">
           <a:extLst>
             <a:ext uri="{FF2B5EF4-FFF2-40B4-BE49-F238E27FC236}">
-              <a16:creationId xmlns:a16="http://schemas.microsoft.com/office/drawing/2014/main" id="{00DE8782-8908-B2D9-2A4B-CF517459B695}"/>
+              <a16:creationId xmlns:a16="http://schemas.microsoft.com/office/drawing/2014/main" id="{A5AC7BBA-F14E-AA00-0072-66420EE8A5EE}"/>
             </a:ext>
           </a:extLst>
         </p:cNvPr>
@@ -3550,7 +3558,7 @@
           <p:cNvPr id="2" name="TextBox 1">
             <a:extLst>
               <a:ext uri="{FF2B5EF4-FFF2-40B4-BE49-F238E27FC236}">
-                <a16:creationId xmlns:a16="http://schemas.microsoft.com/office/drawing/2014/main" id="{6FAAF47B-C242-696E-EF28-E0804196B1FE}"/>
+                <a16:creationId xmlns:a16="http://schemas.microsoft.com/office/drawing/2014/main" id="{488CCEF8-2B7D-53B9-B66F-6AD4173CD186}"/>
               </a:ext>
             </a:extLst>
           </p:cNvPr>
@@ -3573,7 +3581,21 @@
           </a:bodyPr>
           <a:lstStyle/>
           <a:p>
-            <a:pPr algn="l">
+            <a:pPr marL="0" marR="0" lvl="0" indent="0" algn="l" defTabSz="457200" rtl="0" eaLnBrk="1" fontAlgn="auto" latinLnBrk="0" hangingPunct="1">
+              <a:lnSpc>
+                <a:spcPct val="100000"/>
+              </a:lnSpc>
+              <a:spcBef>
+                <a:spcPts val="0"/>
+              </a:spcBef>
+              <a:spcAft>
+                <a:spcPts val="0"/>
+              </a:spcAft>
+              <a:buClrTx/>
+              <a:buSzTx/>
+              <a:buFontTx/>
+              <a:buNone/>
+              <a:tabLst/>
               <a:defRPr sz="2400" b="1">
                 <a:solidFill>
                   <a:srgbClr val="DAA520"/>
@@ -3581,6 +3603,20 @@
               </a:defRPr>
             </a:pPr>
             <a:r>
+              <a:rPr kumimoji="0" sz="2400" b="1" i="0" u="none" strike="noStrike" kern="1200" cap="none" spc="0" normalizeH="0" baseline="0" noProof="0">
+                <a:ln>
+                  <a:noFill/>
+                </a:ln>
+                <a:solidFill>
+                  <a:srgbClr val="DAA520"/>
+                </a:solidFill>
+                <a:effectLst/>
+                <a:uLnTx/>
+                <a:uFillTx/>
+                <a:latin typeface="Calibri"/>
+                <a:ea typeface="+mn-ea"/>
+                <a:cs typeface="+mn-cs"/>
+              </a:rPr>
               <a:t>Research Poster</a:t>
             </a:r>
           </a:p>
@@ -3591,7 +3627,7 @@
           <p:cNvPr id="3" name="Picture 2" descr="image.png">
             <a:extLst>
               <a:ext uri="{FF2B5EF4-FFF2-40B4-BE49-F238E27FC236}">
-                <a16:creationId xmlns:a16="http://schemas.microsoft.com/office/drawing/2014/main" id="{BEA203F5-304D-01A7-314B-3EEED9000CC9}"/>
+                <a16:creationId xmlns:a16="http://schemas.microsoft.com/office/drawing/2014/main" id="{C7E33F19-7596-8C53-C1C8-A58CA67DD1EE}"/>
               </a:ext>
             </a:extLst>
           </p:cNvPr>
@@ -3619,7 +3655,7 @@
     </p:spTree>
     <p:extLst>
       <p:ext uri="{BB962C8B-B14F-4D97-AF65-F5344CB8AC3E}">
-        <p14:creationId xmlns:p14="http://schemas.microsoft.com/office/powerpoint/2010/main" val="1801527513"/>
+        <p14:creationId xmlns:p14="http://schemas.microsoft.com/office/powerpoint/2010/main" val="929685004"/>
       </p:ext>
     </p:extLst>
   </p:cSld>
@@ -4157,12 +4193,20 @@
 <file path=ppt/slides/slide6.xml><?xml version="1.0" encoding="utf-8"?>
 <p:sld xmlns:a="http://schemas.openxmlformats.org/drawingml/2006/main" xmlns:r="http://schemas.openxmlformats.org/officeDocument/2006/relationships" xmlns:p="http://schemas.openxmlformats.org/presentationml/2006/main">
   <p:cSld>
+    <p:bg>
+      <p:bgPr>
+        <a:solidFill>
+          <a:srgbClr val="111320"/>
+        </a:solidFill>
+        <a:effectLst/>
+      </p:bgPr>
+    </p:bg>
     <p:spTree>
       <p:nvGrpSpPr>
         <p:cNvPr id="1" name="">
           <a:extLst>
             <a:ext uri="{FF2B5EF4-FFF2-40B4-BE49-F238E27FC236}">
-              <a16:creationId xmlns:a16="http://schemas.microsoft.com/office/drawing/2014/main" id="{C8FB01FE-6DDC-2147-1EC3-0F82E9A8A975}"/>
+              <a16:creationId xmlns:a16="http://schemas.microsoft.com/office/drawing/2014/main" id="{C362FB1D-B498-E6B8-33C1-68C2EBB255F5}"/>
             </a:ext>
           </a:extLst>
         </p:cNvPr>
@@ -4182,7 +4226,7 @@
           <p:cNvPr id="2" name="TextBox 1">
             <a:extLst>
               <a:ext uri="{FF2B5EF4-FFF2-40B4-BE49-F238E27FC236}">
-                <a16:creationId xmlns:a16="http://schemas.microsoft.com/office/drawing/2014/main" id="{2649DEB8-B841-13DD-5A39-9C52BA27C202}"/>
+                <a16:creationId xmlns:a16="http://schemas.microsoft.com/office/drawing/2014/main" id="{FC49D154-2B37-4CA7-ED41-0693F7E12FCB}"/>
               </a:ext>
             </a:extLst>
           </p:cNvPr>
@@ -4205,7 +4249,21 @@
           </a:bodyPr>
           <a:lstStyle/>
           <a:p>
-            <a:pPr algn="l">
+            <a:pPr marL="0" marR="0" lvl="0" indent="0" algn="l" defTabSz="457200" rtl="0" eaLnBrk="1" fontAlgn="auto" latinLnBrk="0" hangingPunct="1">
+              <a:lnSpc>
+                <a:spcPct val="100000"/>
+              </a:lnSpc>
+              <a:spcBef>
+                <a:spcPts val="0"/>
+              </a:spcBef>
+              <a:spcAft>
+                <a:spcPts val="0"/>
+              </a:spcAft>
+              <a:buClrTx/>
+              <a:buSzTx/>
+              <a:buFontTx/>
+              <a:buNone/>
+              <a:tabLst/>
               <a:defRPr sz="2400" b="1">
                 <a:solidFill>
                   <a:srgbClr val="DAA520"/>
@@ -4213,6 +4271,20 @@
               </a:defRPr>
             </a:pPr>
             <a:r>
+              <a:rPr kumimoji="0" sz="2400" b="1" i="0" u="none" strike="noStrike" kern="1200" cap="none" spc="0" normalizeH="0" baseline="0" noProof="0">
+                <a:ln>
+                  <a:noFill/>
+                </a:ln>
+                <a:solidFill>
+                  <a:srgbClr val="DAA520"/>
+                </a:solidFill>
+                <a:effectLst/>
+                <a:uLnTx/>
+                <a:uFillTx/>
+                <a:latin typeface="Calibri"/>
+                <a:ea typeface="+mn-ea"/>
+                <a:cs typeface="+mn-cs"/>
+              </a:rPr>
               <a:t>Research Poster</a:t>
             </a:r>
           </a:p>
@@ -4223,7 +4295,7 @@
           <p:cNvPr id="3" name="Picture 2" descr="image.png">
             <a:extLst>
               <a:ext uri="{FF2B5EF4-FFF2-40B4-BE49-F238E27FC236}">
-                <a16:creationId xmlns:a16="http://schemas.microsoft.com/office/drawing/2014/main" id="{059F7BBA-6C18-C794-0BC4-1E3C1D7F3D3F}"/>
+                <a16:creationId xmlns:a16="http://schemas.microsoft.com/office/drawing/2014/main" id="{89D1B286-B045-BE9B-D667-B0925762D3F2}"/>
               </a:ext>
             </a:extLst>
           </p:cNvPr>
@@ -4251,7 +4323,7 @@
     </p:spTree>
     <p:extLst>
       <p:ext uri="{BB962C8B-B14F-4D97-AF65-F5344CB8AC3E}">
-        <p14:creationId xmlns:p14="http://schemas.microsoft.com/office/powerpoint/2010/main" val="130865193"/>
+        <p14:creationId xmlns:p14="http://schemas.microsoft.com/office/powerpoint/2010/main" val="810911945"/>
       </p:ext>
     </p:extLst>
   </p:cSld>

</xml_diff>